<commit_message>
docs: add demo video and refresh pitch materials
</commit_message>
<xml_diff>
--- a/docs/TripRescue-pitch.pptx
+++ b/docs/TripRescue-pitch.pptx
@@ -3139,7 +3139,7 @@
                 <a:ea typeface="Cambria" pitchFamily="34" charset="-122"/>
                 <a:cs typeface="Cambria" pitchFamily="34" charset="-120"/>
               </a:rPr>
-              <a:t>38</a:t>
+              <a:t>93</a:t>
             </a:r>
             <a:endParaRPr lang="en-US" sz="6000" dirty="0"/>
           </a:p>
@@ -14194,7 +14194,7 @@
                 <a:ea typeface="Calibri" pitchFamily="34" charset="-122"/>
                 <a:cs typeface="Calibri" pitchFamily="34" charset="-120"/>
               </a:rPr>
-              <a:t>38 automated tests · deterministic policy · full decision trace in the UI</a:t>
+              <a:t>93 automated tests · deterministic policy · full decision trace in the UI</a:t>
             </a:r>
             <a:endParaRPr lang="en-US" sz="1300" dirty="0"/>
           </a:p>

</xml_diff>